<commit_message>
Auto commit on change detected at lun. 26 mai 2025 23:31:39
</commit_message>
<xml_diff>
--- a/IRT2/Q2/Math info/Math_S2_STD.pptx
+++ b/IRT2/Q2/Math info/Math_S2_STD.pptx
@@ -235,7 +235,7 @@
           <a:p>
             <a:fld id="{DB8D3EB8-6AD6-4DF3-B16B-A9E0B517D683}" type="datetimeFigureOut">
               <a:rPr lang="fr-BE" smtClean="0"/>
-              <a:t>11-02-25</a:t>
+              <a:t>26-05-25</a:t>
             </a:fld>
             <a:endParaRPr lang="fr-BE"/>
           </a:p>
@@ -400,7 +400,7 @@
           <a:p>
             <a:fld id="{11702AF6-C27A-47C0-BCF6-EC35CFE95046}" type="datetimeFigureOut">
               <a:rPr lang="fr-BE" smtClean="0"/>
-              <a:t>11-02-25</a:t>
+              <a:t>26-05-25</a:t>
             </a:fld>
             <a:endParaRPr lang="fr-BE"/>
           </a:p>
@@ -733,7 +733,7 @@
           <a:p>
             <a:fld id="{6C02FF5F-0C64-4FEE-B2DF-F912BCEEA8E0}" type="slidenum">
               <a:rPr lang="fr-BE" smtClean="0"/>
-              <a:t>4</a:t>
+              <a:t>1</a:t>
             </a:fld>
             <a:endParaRPr lang="fr-BE"/>
           </a:p>
@@ -742,7 +742,7 @@
     </p:spTree>
     <p:extLst>
       <p:ext uri="{BB962C8B-B14F-4D97-AF65-F5344CB8AC3E}">
-        <p14:creationId xmlns:p14="http://schemas.microsoft.com/office/powerpoint/2010/main" val="3841292507"/>
+        <p14:creationId xmlns:p14="http://schemas.microsoft.com/office/powerpoint/2010/main" val="1429567575"/>
       </p:ext>
     </p:extLst>
   </p:cSld>
@@ -817,7 +817,7 @@
           <a:p>
             <a:fld id="{6C02FF5F-0C64-4FEE-B2DF-F912BCEEA8E0}" type="slidenum">
               <a:rPr lang="fr-BE" smtClean="0"/>
-              <a:t>6</a:t>
+              <a:t>4</a:t>
             </a:fld>
             <a:endParaRPr lang="fr-BE"/>
           </a:p>
@@ -826,7 +826,7 @@
     </p:spTree>
     <p:extLst>
       <p:ext uri="{BB962C8B-B14F-4D97-AF65-F5344CB8AC3E}">
-        <p14:creationId xmlns:p14="http://schemas.microsoft.com/office/powerpoint/2010/main" val="270500083"/>
+        <p14:creationId xmlns:p14="http://schemas.microsoft.com/office/powerpoint/2010/main" val="3841292507"/>
       </p:ext>
     </p:extLst>
   </p:cSld>
@@ -880,7 +880,6 @@
           <a:bodyPr/>
           <a:lstStyle/>
           <a:p>
-            <a:pPr algn="l"/>
             <a:endParaRPr lang="fr-BE" dirty="0"/>
           </a:p>
         </p:txBody>
@@ -902,7 +901,7 @@
           <a:p>
             <a:fld id="{6C02FF5F-0C64-4FEE-B2DF-F912BCEEA8E0}" type="slidenum">
               <a:rPr lang="fr-BE" smtClean="0"/>
-              <a:t>7</a:t>
+              <a:t>6</a:t>
             </a:fld>
             <a:endParaRPr lang="fr-BE"/>
           </a:p>
@@ -911,7 +910,7 @@
     </p:spTree>
     <p:extLst>
       <p:ext uri="{BB962C8B-B14F-4D97-AF65-F5344CB8AC3E}">
-        <p14:creationId xmlns:p14="http://schemas.microsoft.com/office/powerpoint/2010/main" val="1161202092"/>
+        <p14:creationId xmlns:p14="http://schemas.microsoft.com/office/powerpoint/2010/main" val="270500083"/>
       </p:ext>
     </p:extLst>
   </p:cSld>
@@ -987,7 +986,7 @@
           <a:p>
             <a:fld id="{6C02FF5F-0C64-4FEE-B2DF-F912BCEEA8E0}" type="slidenum">
               <a:rPr lang="fr-BE" smtClean="0"/>
-              <a:t>9</a:t>
+              <a:t>7</a:t>
             </a:fld>
             <a:endParaRPr lang="fr-BE"/>
           </a:p>
@@ -996,7 +995,7 @@
     </p:spTree>
     <p:extLst>
       <p:ext uri="{BB962C8B-B14F-4D97-AF65-F5344CB8AC3E}">
-        <p14:creationId xmlns:p14="http://schemas.microsoft.com/office/powerpoint/2010/main" val="1543267751"/>
+        <p14:creationId xmlns:p14="http://schemas.microsoft.com/office/powerpoint/2010/main" val="1161202092"/>
       </p:ext>
     </p:extLst>
   </p:cSld>
@@ -1050,6 +1049,7 @@
           <a:bodyPr/>
           <a:lstStyle/>
           <a:p>
+            <a:pPr algn="l"/>
             <a:endParaRPr lang="fr-BE" dirty="0"/>
           </a:p>
         </p:txBody>
@@ -1071,6 +1071,90 @@
           <a:p>
             <a:fld id="{6C02FF5F-0C64-4FEE-B2DF-F912BCEEA8E0}" type="slidenum">
               <a:rPr lang="fr-BE" smtClean="0"/>
+              <a:t>9</a:t>
+            </a:fld>
+            <a:endParaRPr lang="fr-BE"/>
+          </a:p>
+        </p:txBody>
+      </p:sp>
+    </p:spTree>
+    <p:extLst>
+      <p:ext uri="{BB962C8B-B14F-4D97-AF65-F5344CB8AC3E}">
+        <p14:creationId xmlns:p14="http://schemas.microsoft.com/office/powerpoint/2010/main" val="1543267751"/>
+      </p:ext>
+    </p:extLst>
+  </p:cSld>
+  <p:clrMapOvr>
+    <a:masterClrMapping/>
+  </p:clrMapOvr>
+</p:notes>
+</file>
+
+<file path=ppt/notesSlides/notesSlide6.xml><?xml version="1.0" encoding="utf-8"?>
+<p:notes xmlns:a="http://schemas.openxmlformats.org/drawingml/2006/main" xmlns:r="http://schemas.openxmlformats.org/officeDocument/2006/relationships" xmlns:p="http://schemas.openxmlformats.org/presentationml/2006/main">
+  <p:cSld>
+    <p:spTree>
+      <p:nvGrpSpPr>
+        <p:cNvPr id="1" name=""/>
+        <p:cNvGrpSpPr/>
+        <p:nvPr/>
+      </p:nvGrpSpPr>
+      <p:grpSpPr>
+        <a:xfrm>
+          <a:off x="0" y="0"/>
+          <a:ext cx="0" cy="0"/>
+          <a:chOff x="0" y="0"/>
+          <a:chExt cx="0" cy="0"/>
+        </a:xfrm>
+      </p:grpSpPr>
+      <p:sp>
+        <p:nvSpPr>
+          <p:cNvPr id="2" name="Espace réservé de l'image des diapositives 1"/>
+          <p:cNvSpPr>
+            <a:spLocks noGrp="1" noRot="1" noChangeAspect="1"/>
+          </p:cNvSpPr>
+          <p:nvPr>
+            <p:ph type="sldImg"/>
+          </p:nvPr>
+        </p:nvSpPr>
+        <p:spPr/>
+      </p:sp>
+      <p:sp>
+        <p:nvSpPr>
+          <p:cNvPr id="3" name="Espace réservé des notes 2"/>
+          <p:cNvSpPr>
+            <a:spLocks noGrp="1"/>
+          </p:cNvSpPr>
+          <p:nvPr>
+            <p:ph type="body" idx="1"/>
+          </p:nvPr>
+        </p:nvSpPr>
+        <p:spPr/>
+        <p:txBody>
+          <a:bodyPr/>
+          <a:lstStyle/>
+          <a:p>
+            <a:endParaRPr lang="fr-BE" dirty="0"/>
+          </a:p>
+        </p:txBody>
+      </p:sp>
+      <p:sp>
+        <p:nvSpPr>
+          <p:cNvPr id="4" name="Espace réservé du numéro de diapositive 3"/>
+          <p:cNvSpPr>
+            <a:spLocks noGrp="1"/>
+          </p:cNvSpPr>
+          <p:nvPr>
+            <p:ph type="sldNum" sz="quarter" idx="5"/>
+          </p:nvPr>
+        </p:nvSpPr>
+        <p:spPr/>
+        <p:txBody>
+          <a:bodyPr/>
+          <a:lstStyle/>
+          <a:p>
+            <a:fld id="{6C02FF5F-0C64-4FEE-B2DF-F912BCEEA8E0}" type="slidenum">
+              <a:rPr lang="fr-BE" smtClean="0"/>
               <a:t>10</a:t>
             </a:fld>
             <a:endParaRPr lang="fr-BE"/>
@@ -1090,7 +1174,7 @@
 </p:notes>
 </file>
 
-<file path=ppt/notesSlides/notesSlide6.xml><?xml version="1.0" encoding="utf-8"?>
+<file path=ppt/notesSlides/notesSlide7.xml><?xml version="1.0" encoding="utf-8"?>
 <p:notes xmlns:a="http://schemas.openxmlformats.org/drawingml/2006/main" xmlns:r="http://schemas.openxmlformats.org/officeDocument/2006/relationships" xmlns:p="http://schemas.openxmlformats.org/presentationml/2006/main">
   <p:cSld>
     <p:spTree>
@@ -4369,8 +4453,8 @@
           </a:p>
         </p:txBody>
       </p:sp>
-      <mc:AlternateContent xmlns:mc="http://schemas.openxmlformats.org/markup-compatibility/2006">
-        <mc:Choice xmlns:a14="http://schemas.microsoft.com/office/drawing/2010/main" Requires="a14">
+      <mc:AlternateContent xmlns:mc="http://schemas.openxmlformats.org/markup-compatibility/2006" xmlns:a14="http://schemas.microsoft.com/office/drawing/2010/main">
+        <mc:Choice Requires="a14">
           <p:sp>
             <p:nvSpPr>
               <p:cNvPr id="3" name="Titre 2">
@@ -4416,7 +4500,7 @@
             </p:txBody>
           </p:sp>
         </mc:Choice>
-        <mc:Fallback>
+        <mc:Fallback xmlns="">
           <p:sp>
             <p:nvSpPr>
               <p:cNvPr id="3" name="Titre 2">
@@ -4976,8 +5060,8 @@
           </a:p>
         </p:txBody>
       </p:sp>
-      <mc:AlternateContent xmlns:mc="http://schemas.openxmlformats.org/markup-compatibility/2006">
-        <mc:Choice xmlns:a14="http://schemas.microsoft.com/office/drawing/2010/main" Requires="a14">
+      <mc:AlternateContent xmlns:mc="http://schemas.openxmlformats.org/markup-compatibility/2006" xmlns:a14="http://schemas.microsoft.com/office/drawing/2010/main">
+        <mc:Choice Requires="a14">
           <p:sp>
             <p:nvSpPr>
               <p:cNvPr id="3" name="Titre 2">
@@ -5019,7 +5103,7 @@
             </p:txBody>
           </p:sp>
         </mc:Choice>
-        <mc:Fallback>
+        <mc:Fallback xmlns="">
           <p:sp>
             <p:nvSpPr>
               <p:cNvPr id="3" name="Titre 2">
@@ -10274,7 +10358,7 @@
           <a:bodyPr/>
           <a:lstStyle/>
           <a:p>
-            <a:endParaRPr lang="fr-BE"/>
+            <a:endParaRPr lang="fr-BE" dirty="0"/>
           </a:p>
         </p:txBody>
       </p:sp>
@@ -10580,8 +10664,8 @@
           <a:chExt cx="0" cy="0"/>
         </a:xfrm>
       </p:grpSpPr>
-      <mc:AlternateContent xmlns:mc="http://schemas.openxmlformats.org/markup-compatibility/2006">
-        <mc:Choice xmlns:a14="http://schemas.microsoft.com/office/drawing/2010/main" Requires="a14">
+      <mc:AlternateContent xmlns:mc="http://schemas.openxmlformats.org/markup-compatibility/2006" xmlns:a14="http://schemas.microsoft.com/office/drawing/2010/main">
+        <mc:Choice Requires="a14">
           <p:sp>
             <p:nvSpPr>
               <p:cNvPr id="2" name="Espace réservé du contenu 1">
@@ -10754,7 +10838,7 @@
             </p:txBody>
           </p:sp>
         </mc:Choice>
-        <mc:Fallback>
+        <mc:Fallback xmlns="">
           <p:sp>
             <p:nvSpPr>
               <p:cNvPr id="2" name="Espace réservé du contenu 1">
@@ -11124,8 +11208,8 @@
           <a:chExt cx="0" cy="0"/>
         </a:xfrm>
       </p:grpSpPr>
-      <mc:AlternateContent xmlns:mc="http://schemas.openxmlformats.org/markup-compatibility/2006">
-        <mc:Choice xmlns:a14="http://schemas.microsoft.com/office/drawing/2010/main" Requires="a14">
+      <mc:AlternateContent xmlns:mc="http://schemas.openxmlformats.org/markup-compatibility/2006" xmlns:a14="http://schemas.microsoft.com/office/drawing/2010/main">
+        <mc:Choice Requires="a14">
           <p:sp>
             <p:nvSpPr>
               <p:cNvPr id="2" name="Espace réservé du contenu 1">
@@ -11370,7 +11454,7 @@
             </p:txBody>
           </p:sp>
         </mc:Choice>
-        <mc:Fallback>
+        <mc:Fallback xmlns="">
           <p:sp>
             <p:nvSpPr>
               <p:cNvPr id="2" name="Espace réservé du contenu 1">
@@ -11973,8 +12057,8 @@
           <a:chExt cx="0" cy="0"/>
         </a:xfrm>
       </p:grpSpPr>
-      <mc:AlternateContent xmlns:mc="http://schemas.openxmlformats.org/markup-compatibility/2006">
-        <mc:Choice xmlns:a14="http://schemas.microsoft.com/office/drawing/2010/main" Requires="a14">
+      <mc:AlternateContent xmlns:mc="http://schemas.openxmlformats.org/markup-compatibility/2006" xmlns:a14="http://schemas.microsoft.com/office/drawing/2010/main">
+        <mc:Choice Requires="a14">
           <p:sp>
             <p:nvSpPr>
               <p:cNvPr id="2" name="Espace réservé du contenu 1">
@@ -12027,13 +12111,7 @@
                       <a:rPr lang="fr-FR" b="0" i="1" smtClean="0">
                         <a:latin typeface="Cambria Math" panose="02040503050406030204" pitchFamily="18" charset="0"/>
                       </a:rPr>
-                      <m:t>≤</m:t>
-                    </m:r>
-                    <m:r>
-                      <a:rPr lang="fr-FR" b="0" i="1" smtClean="0">
-                        <a:latin typeface="Cambria Math" panose="02040503050406030204" pitchFamily="18" charset="0"/>
-                      </a:rPr>
-                      <m:t>2∗</m:t>
+                      <m:t>≤2∗</m:t>
                     </m:r>
                     <m:sSub>
                       <m:sSubPr>
@@ -12070,13 +12148,7 @@
                       <a:rPr lang="fr-FR" b="0" i="1" smtClean="0">
                         <a:latin typeface="Cambria Math" panose="02040503050406030204" pitchFamily="18" charset="0"/>
                       </a:rPr>
-                      <m:t>+1</m:t>
-                    </m:r>
-                    <m:r>
-                      <a:rPr lang="fr-FR" b="0" i="1" smtClean="0">
-                        <a:latin typeface="Cambria Math" panose="02040503050406030204" pitchFamily="18" charset="0"/>
-                      </a:rPr>
-                      <m:t> </m:t>
+                      <m:t>+1 </m:t>
                     </m:r>
                     <m:r>
                       <a:rPr lang="fr-FR" b="0" i="1" smtClean="0">
@@ -12157,13 +12229,7 @@
                       <a:rPr lang="fr-FR" b="0" i="1" smtClean="0">
                         <a:latin typeface="Cambria Math" panose="02040503050406030204" pitchFamily="18" charset="0"/>
                       </a:rPr>
-                      <m:t>≥</m:t>
-                    </m:r>
-                    <m:r>
-                      <a:rPr lang="fr-FR" b="0" i="1" smtClean="0">
-                        <a:latin typeface="Cambria Math" panose="02040503050406030204" pitchFamily="18" charset="0"/>
-                      </a:rPr>
-                      <m:t>2</m:t>
+                      <m:t>≥2</m:t>
                     </m:r>
                     <m:sSub>
                       <m:sSubPr>
@@ -12230,13 +12296,7 @@
                       <a:rPr lang="fr-FR" b="0" i="1" smtClean="0">
                         <a:latin typeface="Cambria Math" panose="02040503050406030204" pitchFamily="18" charset="0"/>
                       </a:rPr>
-                      <m:t>&gt;</m:t>
-                    </m:r>
-                    <m:r>
-                      <a:rPr lang="fr-FR" b="0" i="1" smtClean="0">
-                        <a:latin typeface="Cambria Math" panose="02040503050406030204" pitchFamily="18" charset="0"/>
-                      </a:rPr>
-                      <m:t>0</m:t>
+                      <m:t>&gt;0</m:t>
                     </m:r>
                   </m:oMath>
                 </a14:m>
@@ -12248,7 +12308,7 @@
             </p:txBody>
           </p:sp>
         </mc:Choice>
-        <mc:Fallback>
+        <mc:Fallback xmlns="">
           <p:sp>
             <p:nvSpPr>
               <p:cNvPr id="2" name="Espace réservé du contenu 1">
@@ -12558,8 +12618,8 @@
           <a:chExt cx="0" cy="0"/>
         </a:xfrm>
       </p:grpSpPr>
-      <mc:AlternateContent xmlns:mc="http://schemas.openxmlformats.org/markup-compatibility/2006">
-        <mc:Choice xmlns:a14="http://schemas.microsoft.com/office/drawing/2010/main" Requires="a14">
+      <mc:AlternateContent xmlns:mc="http://schemas.openxmlformats.org/markup-compatibility/2006" xmlns:a14="http://schemas.microsoft.com/office/drawing/2010/main">
+        <mc:Choice Requires="a14">
           <p:sp>
             <p:nvSpPr>
               <p:cNvPr id="2" name="Espace réservé du contenu 1">
@@ -12722,13 +12782,7 @@
                       <a:rPr lang="fr-FR" b="0" i="1" smtClean="0">
                         <a:latin typeface="Cambria Math" panose="02040503050406030204" pitchFamily="18" charset="0"/>
                       </a:rPr>
-                      <m:t>≥</m:t>
-                    </m:r>
-                    <m:r>
-                      <a:rPr lang="fr-FR" b="0" i="1" smtClean="0">
-                        <a:latin typeface="Cambria Math" panose="02040503050406030204" pitchFamily="18" charset="0"/>
-                      </a:rPr>
-                      <m:t>2∗</m:t>
+                      <m:t>≥2∗</m:t>
                     </m:r>
                     <m:sSub>
                       <m:sSubPr>
@@ -12936,13 +12990,7 @@
                       <a:rPr lang="fr-FR" b="0" i="1" smtClean="0">
                         <a:latin typeface="Cambria Math" panose="02040503050406030204" pitchFamily="18" charset="0"/>
                       </a:rPr>
-                      <m:t>=</m:t>
-                    </m:r>
-                    <m:r>
-                      <a:rPr lang="fr-FR" b="0" i="1" smtClean="0">
-                        <a:latin typeface="Cambria Math" panose="02040503050406030204" pitchFamily="18" charset="0"/>
-                      </a:rPr>
-                      <m:t>2∗</m:t>
+                      <m:t>=2∗</m:t>
                     </m:r>
                     <m:sSub>
                       <m:sSubPr>
@@ -13021,7 +13069,7 @@
             </p:txBody>
           </p:sp>
         </mc:Choice>
-        <mc:Fallback>
+        <mc:Fallback xmlns="">
           <p:sp>
             <p:nvSpPr>
               <p:cNvPr id="2" name="Espace réservé du contenu 1">
@@ -13453,8 +13501,8 @@
           <a:chExt cx="0" cy="0"/>
         </a:xfrm>
       </p:grpSpPr>
-      <mc:AlternateContent xmlns:mc="http://schemas.openxmlformats.org/markup-compatibility/2006">
-        <mc:Choice xmlns:a14="http://schemas.microsoft.com/office/drawing/2010/main" Requires="a14">
+      <mc:AlternateContent xmlns:mc="http://schemas.openxmlformats.org/markup-compatibility/2006" xmlns:a14="http://schemas.microsoft.com/office/drawing/2010/main">
+        <mc:Choice Requires="a14">
           <p:sp>
             <p:nvSpPr>
               <p:cNvPr id="2" name="Espace réservé du contenu 1">
@@ -13700,13 +13748,7 @@
                       <a:rPr lang="fr-FR" b="0" i="1" smtClean="0">
                         <a:latin typeface="Cambria Math" panose="02040503050406030204" pitchFamily="18" charset="0"/>
                       </a:rPr>
-                      <m:t>+1</m:t>
-                    </m:r>
-                    <m:r>
-                      <a:rPr lang="fr-FR" b="0" i="1" smtClean="0">
-                        <a:latin typeface="Cambria Math" panose="02040503050406030204" pitchFamily="18" charset="0"/>
-                      </a:rPr>
-                      <m:t>=1 </m:t>
+                      <m:t>+1=1 </m:t>
                     </m:r>
                     <m:d>
                       <m:dPr>
@@ -13792,13 +13834,7 @@
                       <a:rPr lang="fr-FR" b="0" i="1" smtClean="0">
                         <a:latin typeface="Cambria Math" panose="02040503050406030204" pitchFamily="18" charset="0"/>
                       </a:rPr>
-                      <m:t>+1</m:t>
-                    </m:r>
-                    <m:r>
-                      <a:rPr lang="fr-FR" b="0" i="1" smtClean="0">
-                        <a:latin typeface="Cambria Math" panose="02040503050406030204" pitchFamily="18" charset="0"/>
-                      </a:rPr>
-                      <m:t>=2∗1+1=3 </m:t>
+                      <m:t>+1=2∗1+1=3 </m:t>
                     </m:r>
                     <m:d>
                       <m:dPr>
@@ -13884,13 +13920,7 @@
                       <a:rPr lang="fr-FR" b="0" i="1" smtClean="0">
                         <a:latin typeface="Cambria Math" panose="02040503050406030204" pitchFamily="18" charset="0"/>
                       </a:rPr>
-                      <m:t>+1</m:t>
-                    </m:r>
-                    <m:r>
-                      <a:rPr lang="fr-FR" b="0" i="1" smtClean="0">
-                        <a:latin typeface="Cambria Math" panose="02040503050406030204" pitchFamily="18" charset="0"/>
-                      </a:rPr>
-                      <m:t>=2∗3+1=7</m:t>
+                      <m:t>+1=2∗3+1=7</m:t>
                     </m:r>
                   </m:oMath>
                 </a14:m>
@@ -13965,13 +13995,7 @@
                       <a:rPr lang="fr-FR" b="0" i="1" smtClean="0">
                         <a:latin typeface="Cambria Math" panose="02040503050406030204" pitchFamily="18" charset="0"/>
                       </a:rPr>
-                      <m:t>+1</m:t>
-                    </m:r>
-                    <m:r>
-                      <a:rPr lang="fr-FR" b="0" i="1" smtClean="0">
-                        <a:latin typeface="Cambria Math" panose="02040503050406030204" pitchFamily="18" charset="0"/>
-                      </a:rPr>
-                      <m:t>= ?</m:t>
+                      <m:t>+1= ?</m:t>
                     </m:r>
                   </m:oMath>
                 </a14:m>
@@ -13980,7 +14004,7 @@
             </p:txBody>
           </p:sp>
         </mc:Choice>
-        <mc:Fallback>
+        <mc:Fallback xmlns="">
           <p:sp>
             <p:nvSpPr>
               <p:cNvPr id="2" name="Espace réservé du contenu 1">
@@ -14859,8 +14883,8 @@
           <a:chExt cx="0" cy="0"/>
         </a:xfrm>
       </p:grpSpPr>
-      <mc:AlternateContent xmlns:mc="http://schemas.openxmlformats.org/markup-compatibility/2006">
-        <mc:Choice xmlns:a14="http://schemas.microsoft.com/office/drawing/2010/main" Requires="a14">
+      <mc:AlternateContent xmlns:mc="http://schemas.openxmlformats.org/markup-compatibility/2006" xmlns:a14="http://schemas.microsoft.com/office/drawing/2010/main">
+        <mc:Choice Requires="a14">
           <p:sp>
             <p:nvSpPr>
               <p:cNvPr id="2" name="Espace réservé du contenu 1">
@@ -14952,7 +14976,7 @@
             </p:txBody>
           </p:sp>
         </mc:Choice>
-        <mc:Fallback>
+        <mc:Fallback xmlns="">
           <p:sp>
             <p:nvSpPr>
               <p:cNvPr id="2" name="Espace réservé du contenu 1">
@@ -15322,8 +15346,8 @@
           <a:chExt cx="0" cy="0"/>
         </a:xfrm>
       </p:grpSpPr>
-      <mc:AlternateContent xmlns:mc="http://schemas.openxmlformats.org/markup-compatibility/2006">
-        <mc:Choice xmlns:a14="http://schemas.microsoft.com/office/drawing/2010/main" Requires="a14">
+      <mc:AlternateContent xmlns:mc="http://schemas.openxmlformats.org/markup-compatibility/2006" xmlns:a14="http://schemas.microsoft.com/office/drawing/2010/main">
+        <mc:Choice Requires="a14">
           <p:sp>
             <p:nvSpPr>
               <p:cNvPr id="2" name="Espace réservé du contenu 1">
@@ -15390,13 +15414,7 @@
                         <a:rPr lang="fr-FR" b="0" i="1" smtClean="0">
                           <a:latin typeface="Cambria Math" panose="02040503050406030204" pitchFamily="18" charset="0"/>
                         </a:rPr>
-                        <m:t>=</m:t>
-                      </m:r>
-                      <m:r>
-                        <a:rPr lang="fr-FR" b="0" i="1" smtClean="0">
-                          <a:latin typeface="Cambria Math" panose="02040503050406030204" pitchFamily="18" charset="0"/>
-                        </a:rPr>
-                        <m:t>3</m:t>
+                        <m:t>=3</m:t>
                       </m:r>
                     </m:oMath>
                   </m:oMathPara>
@@ -15442,13 +15460,7 @@
                         <a:rPr lang="fr-FR" b="0" i="1" smtClean="0">
                           <a:latin typeface="Cambria Math" panose="02040503050406030204" pitchFamily="18" charset="0"/>
                         </a:rPr>
-                        <m:t>=</m:t>
-                      </m:r>
-                      <m:r>
-                        <a:rPr lang="fr-FR" b="0" i="1" smtClean="0">
-                          <a:latin typeface="Cambria Math" panose="02040503050406030204" pitchFamily="18" charset="0"/>
-                        </a:rPr>
-                        <m:t>2∗3+1=7</m:t>
+                        <m:t>=2∗3+1=7</m:t>
                       </m:r>
                     </m:oMath>
                   </m:oMathPara>
@@ -15494,25 +15506,7 @@
                         <a:rPr lang="fr-FR" b="0" i="1" smtClean="0">
                           <a:latin typeface="Cambria Math" panose="02040503050406030204" pitchFamily="18" charset="0"/>
                         </a:rPr>
-                        <m:t>=2∗</m:t>
-                      </m:r>
-                      <m:r>
-                        <a:rPr lang="fr-FR" b="0" i="1" smtClean="0">
-                          <a:latin typeface="Cambria Math" panose="02040503050406030204" pitchFamily="18" charset="0"/>
-                        </a:rPr>
-                        <m:t>7</m:t>
-                      </m:r>
-                      <m:r>
-                        <a:rPr lang="fr-FR" b="0" i="1" smtClean="0">
-                          <a:latin typeface="Cambria Math" panose="02040503050406030204" pitchFamily="18" charset="0"/>
-                        </a:rPr>
-                        <m:t>+1=</m:t>
-                      </m:r>
-                      <m:r>
-                        <a:rPr lang="fr-FR" b="0" i="1" smtClean="0">
-                          <a:latin typeface="Cambria Math" panose="02040503050406030204" pitchFamily="18" charset="0"/>
-                        </a:rPr>
-                        <m:t>15</m:t>
+                        <m:t>=2∗7+1=15</m:t>
                       </m:r>
                     </m:oMath>
                   </m:oMathPara>
@@ -15558,25 +15552,7 @@
                         <a:rPr lang="fr-FR" b="0" i="1" smtClean="0">
                           <a:latin typeface="Cambria Math" panose="02040503050406030204" pitchFamily="18" charset="0"/>
                         </a:rPr>
-                        <m:t>=2∗</m:t>
-                      </m:r>
-                      <m:r>
-                        <a:rPr lang="fr-FR" b="0" i="1" smtClean="0">
-                          <a:latin typeface="Cambria Math" panose="02040503050406030204" pitchFamily="18" charset="0"/>
-                        </a:rPr>
-                        <m:t>15</m:t>
-                      </m:r>
-                      <m:r>
-                        <a:rPr lang="fr-FR" b="0" i="1" smtClean="0">
-                          <a:latin typeface="Cambria Math" panose="02040503050406030204" pitchFamily="18" charset="0"/>
-                        </a:rPr>
-                        <m:t>+1=</m:t>
-                      </m:r>
-                      <m:r>
-                        <a:rPr lang="fr-FR" b="0" i="1" smtClean="0">
-                          <a:latin typeface="Cambria Math" panose="02040503050406030204" pitchFamily="18" charset="0"/>
-                        </a:rPr>
-                        <m:t>31</m:t>
+                        <m:t>=2∗15+1=31</m:t>
                       </m:r>
                     </m:oMath>
                   </m:oMathPara>
@@ -15689,7 +15665,7 @@
             </p:txBody>
           </p:sp>
         </mc:Choice>
-        <mc:Fallback>
+        <mc:Fallback xmlns="">
           <p:sp>
             <p:nvSpPr>
               <p:cNvPr id="2" name="Espace réservé du contenu 1">
@@ -16671,8 +16647,8 @@
           </a:p>
         </p:txBody>
       </p:sp>
-      <mc:AlternateContent xmlns:mc="http://schemas.openxmlformats.org/markup-compatibility/2006">
-        <mc:Choice xmlns:a14="http://schemas.microsoft.com/office/drawing/2010/main" Requires="a14">
+      <mc:AlternateContent xmlns:mc="http://schemas.openxmlformats.org/markup-compatibility/2006" xmlns:a14="http://schemas.microsoft.com/office/drawing/2010/main">
+        <mc:Choice Requires="a14">
           <p:graphicFrame>
             <p:nvGraphicFramePr>
               <p:cNvPr id="5" name="Tableau 5">
@@ -16982,7 +16958,7 @@
             </a:graphic>
           </p:graphicFrame>
         </mc:Choice>
-        <mc:Fallback>
+        <mc:Fallback xmlns="">
           <p:graphicFrame>
             <p:nvGraphicFramePr>
               <p:cNvPr id="5" name="Tableau 5">
@@ -20634,53 +20610,6 @@
           </a:p>
         </p:txBody>
       </p:sp>
-      <p:pic>
-        <p:nvPicPr>
-          <p:cNvPr id="5" name="Picture 2" descr="a man wearing glasses and a suit says worst case scenario">
-            <a:extLst>
-              <a:ext uri="{FF2B5EF4-FFF2-40B4-BE49-F238E27FC236}">
-                <a16:creationId xmlns:a16="http://schemas.microsoft.com/office/drawing/2014/main" id="{3FB407D2-1FFE-4D77-9452-0D54E322E310}"/>
-              </a:ext>
-            </a:extLst>
-          </p:cNvPr>
-          <p:cNvPicPr>
-            <a:picLocks noChangeAspect="1" noChangeArrowheads="1" noCrop="1"/>
-          </p:cNvPicPr>
-          <p:nvPr/>
-        </p:nvPicPr>
-        <p:blipFill>
-          <a:blip r:embed="rId3">
-            <a:extLst>
-              <a:ext uri="{28A0092B-C50C-407E-A947-70E740481C1C}">
-                <a14:useLocalDpi xmlns:a14="http://schemas.microsoft.com/office/drawing/2010/main" val="0"/>
-              </a:ext>
-            </a:extLst>
-          </a:blip>
-          <a:srcRect/>
-          <a:stretch>
-            <a:fillRect/>
-          </a:stretch>
-        </p:blipFill>
-        <p:spPr bwMode="auto">
-          <a:xfrm>
-            <a:off x="2449470" y="1139666"/>
-            <a:ext cx="4399005" cy="4887783"/>
-          </a:xfrm>
-          <a:prstGeom prst="rect">
-            <a:avLst/>
-          </a:prstGeom>
-          <a:noFill/>
-          <a:extLst>
-            <a:ext uri="{909E8E84-426E-40DD-AFC4-6F175D3DCCD1}">
-              <a14:hiddenFill xmlns:a14="http://schemas.microsoft.com/office/drawing/2010/main">
-                <a:solidFill>
-                  <a:srgbClr val="FFFFFF"/>
-                </a:solidFill>
-              </a14:hiddenFill>
-            </a:ext>
-          </a:extLst>
-        </p:spPr>
-      </p:pic>
     </p:spTree>
     <p:extLst>
       <p:ext uri="{BB962C8B-B14F-4D97-AF65-F5344CB8AC3E}">
@@ -20877,51 +20806,6 @@
                                               <p:pRg st="5" end="5"/>
                                             </p:txEl>
                                           </p:spTgt>
-                                        </p:tgtEl>
-                                        <p:attrNameLst>
-                                          <p:attrName>style.visibility</p:attrName>
-                                        </p:attrNameLst>
-                                      </p:cBhvr>
-                                      <p:to>
-                                        <p:strVal val="visible"/>
-                                      </p:to>
-                                    </p:set>
-                                  </p:childTnLst>
-                                </p:cTn>
-                              </p:par>
-                            </p:childTnLst>
-                          </p:cTn>
-                        </p:par>
-                      </p:childTnLst>
-                    </p:cTn>
-                  </p:par>
-                  <p:par>
-                    <p:cTn id="19" fill="hold">
-                      <p:stCondLst>
-                        <p:cond delay="indefinite"/>
-                      </p:stCondLst>
-                      <p:childTnLst>
-                        <p:par>
-                          <p:cTn id="20" fill="hold">
-                            <p:stCondLst>
-                              <p:cond delay="0"/>
-                            </p:stCondLst>
-                            <p:childTnLst>
-                              <p:par>
-                                <p:cTn id="21" presetID="1" presetClass="entr" presetSubtype="0" fill="hold" nodeType="clickEffect">
-                                  <p:stCondLst>
-                                    <p:cond delay="0"/>
-                                  </p:stCondLst>
-                                  <p:childTnLst>
-                                    <p:set>
-                                      <p:cBhvr>
-                                        <p:cTn id="22" dur="1" fill="hold">
-                                          <p:stCondLst>
-                                            <p:cond delay="0"/>
-                                          </p:stCondLst>
-                                        </p:cTn>
-                                        <p:tgtEl>
-                                          <p:spTgt spid="5"/>
                                         </p:tgtEl>
                                         <p:attrNameLst>
                                           <p:attrName>style.visibility</p:attrName>

</xml_diff>